<commit_message>
Chungshan Gratitude deck: add Dom's Gratitude animation
New video slide (qQQhU5rkwXE) right before the action slide, asking who
will get the card the students just wrote. Period 1 now plays Dom's SDG 11
animation, so the second period no longer repeats a video.

Co-Authored-By: Claude Opus 5.5 <noreply@anthropic.com>
</commit_message>
<xml_diff>
--- a/slides/chungshan-elem-gratitude/chungshan-elem-gratitude.pptx
+++ b/slides/chungshan-elem-gratitude/chungshan-elem-gratitude.pptx
@@ -29,6 +29,7 @@
     <p:sldId id="277" r:id="rId28"/>
     <p:sldId id="278" r:id="rId29"/>
     <p:sldId id="279" r:id="rId30"/>
+    <p:sldId id="280" r:id="rId31"/>
   </p:sldIdLst>
   <p:sldSz cx="12191695" cy="6858000" type="screen4x3"/>
   <p:notesSz cx="6858000" cy="9144000"/>
@@ -3491,7 +3492,9 @@
       <p:grpSpPr/>
       <p:pic>
         <p:nvPicPr>
-          <p:cNvPr id="2" name="Picture 1" descr="017.png"/>
+          <p:cNvPr id="2" name="Picture 1" descr="017.jpg">
+            <a:hlinkClick r:id="rId3"/>
+          </p:cNvPr>
           <p:cNvPicPr>
             <a:picLocks noChangeAspect="1"/>
           </p:cNvPicPr>
@@ -3786,6 +3789,48 @@
       <p:pic>
         <p:nvPicPr>
           <p:cNvPr id="2" name="Picture 1" descr="023.png"/>
+          <p:cNvPicPr>
+            <a:picLocks noChangeAspect="1"/>
+          </p:cNvPicPr>
+          <p:nvPr/>
+        </p:nvPicPr>
+        <p:blipFill>
+          <a:blip r:embed="rId2"/>
+          <a:stretch>
+            <a:fillRect/>
+          </a:stretch>
+        </p:blipFill>
+        <p:spPr>
+          <a:xfrm>
+            <a:off x="0" y="0"/>
+            <a:ext cx="12191695" cy="6858000"/>
+          </a:xfrm>
+          <a:prstGeom prst="rect">
+            <a:avLst/>
+          </a:prstGeom>
+        </p:spPr>
+      </p:pic>
+    </p:spTree>
+  </p:cSld>
+  <p:clrMapOvr>
+    <a:masterClrMapping/>
+  </p:clrMapOvr>
+</p:sld>
+</file>
+
+<file path=ppt/slides/slide25.xml><?xml version="1.0" encoding="utf-8"?>
+<p:sld xmlns:a="http://schemas.openxmlformats.org/drawingml/2006/main" xmlns:p="http://schemas.openxmlformats.org/presentationml/2006/main" xmlns:r="http://schemas.openxmlformats.org/officeDocument/2006/relationships">
+  <p:cSld>
+    <p:spTree>
+      <p:nvGrpSpPr>
+        <p:cNvPr id="1" name=""/>
+        <p:cNvGrpSpPr/>
+        <p:nvPr/>
+      </p:nvGrpSpPr>
+      <p:grpSpPr/>
+      <p:pic>
+        <p:nvPicPr>
+          <p:cNvPr id="2" name="Picture 1" descr="024.png"/>
           <p:cNvPicPr>
             <a:picLocks noChangeAspect="1"/>
           </p:cNvPicPr>

</xml_diff>